<commit_message>
Remove outdated presentation file and update existing presentation with new content
- Deleted the `PITER_AiOps_Mid_Course_Presentation_Improved.pptx` file to eliminate redundancy.
- Updated `presentation_v1.pptx` with new content to enhance the presentation quality and relevance.

These changes streamline the presentation materials and ensure that only the most current version is available for use.
</commit_message>
<xml_diff>
--- a/projects/piter-aiops/presentation/presentation_v1.pptx
+++ b/projects/piter-aiops/presentation/presentation_v1.pptx
@@ -3,17 +3,19 @@
 <p:presentation xmlns:a="http://schemas.openxmlformats.org/drawingml/2006/main" xmlns:r="http://schemas.openxmlformats.org/officeDocument/2006/relationships" xmlns:p="http://schemas.openxmlformats.org/presentationml/2006/main" saveSubsetFonts="1" autoCompressPictures="0">
   <p:sldMasterIdLst>
     <p:sldMasterId id="2147483648" r:id="rId1"/>
+    <p:sldMasterId id="2147483650" r:id="rId2"/>
   </p:sldMasterIdLst>
   <p:notesMasterIdLst>
-    <p:notesMasterId r:id="rId8"/>
+    <p:notesMasterId r:id="rId10"/>
   </p:notesMasterIdLst>
   <p:sldIdLst>
-    <p:sldId id="256" r:id="rId2"/>
-    <p:sldId id="257" r:id="rId3"/>
-    <p:sldId id="258" r:id="rId4"/>
-    <p:sldId id="259" r:id="rId5"/>
-    <p:sldId id="260" r:id="rId6"/>
-    <p:sldId id="261" r:id="rId7"/>
+    <p:sldId id="256" r:id="rId3"/>
+    <p:sldId id="257" r:id="rId4"/>
+    <p:sldId id="258" r:id="rId5"/>
+    <p:sldId id="259" r:id="rId6"/>
+    <p:sldId id="260" r:id="rId7"/>
+    <p:sldId id="261" r:id="rId8"/>
+    <p:sldId id="262" r:id="rId9"/>
   </p:sldIdLst>
   <p:sldSz cx="9144000" cy="5143500" type="screen16x9"/>
   <p:notesSz cx="5143500" cy="9144000"/>
@@ -746,6 +748,150 @@
 </p:notes>
 </file>
 
+<file path=ppt/notesSlides/notesSlide7.xml><?xml version="1.0" encoding="utf-8"?>
+<p:notes xmlns:a="http://schemas.openxmlformats.org/drawingml/2006/main" xmlns:r="http://schemas.openxmlformats.org/officeDocument/2006/relationships" xmlns:p="http://schemas.openxmlformats.org/presentationml/2006/main">
+  <p:cSld>
+    <p:spTree>
+      <p:nvGrpSpPr>
+        <p:cNvPr id="1" name=""/>
+        <p:cNvGrpSpPr/>
+        <p:nvPr/>
+      </p:nvGrpSpPr>
+      <p:grpSpPr>
+        <a:xfrm>
+          <a:off x="0" y="0"/>
+          <a:ext cx="0" cy="0"/>
+          <a:chOff x="0" y="0"/>
+          <a:chExt cx="0" cy="0"/>
+        </a:xfrm>
+      </p:grpSpPr>
+      <p:sp>
+        <p:nvSpPr>
+          <p:cNvPr id="2" name="Slide Image Placeholder 1"/>
+          <p:cNvSpPr>
+            <a:spLocks noGrp="1" noRot="1" noChangeAspect="1"/>
+          </p:cNvSpPr>
+          <p:nvPr>
+            <p:ph type="sldImg"/>
+          </p:nvPr>
+        </p:nvSpPr>
+        <p:spPr/>
+      </p:sp>
+      <p:sp>
+        <p:nvSpPr>
+          <p:cNvPr id="3" name="Notes Placeholder 2"/>
+          <p:cNvSpPr>
+            <a:spLocks noGrp="1"/>
+          </p:cNvSpPr>
+          <p:nvPr>
+            <p:ph type="body" idx="1"/>
+          </p:nvPr>
+        </p:nvSpPr>
+        <p:spPr/>
+        <p:txBody>
+          <a:bodyPr/>
+          <a:lstStyle/>
+          <a:p>
+            <a:endParaRPr lang="en-US" dirty="0"/>
+          </a:p>
+        </p:txBody>
+      </p:sp>
+      <p:sp>
+        <p:nvSpPr>
+          <p:cNvPr id="4" name="Slide Number Placeholder 3"/>
+          <p:cNvSpPr>
+            <a:spLocks noGrp="1"/>
+          </p:cNvSpPr>
+          <p:nvPr>
+            <p:ph type="sldNum" sz="quarter" idx="10"/>
+          </p:nvPr>
+        </p:nvSpPr>
+        <p:spPr/>
+        <p:txBody>
+          <a:bodyPr/>
+          <a:lstStyle/>
+          <a:p>
+            <a:pPr marL="0" marR="0" lvl="0" indent="0" algn="l" defTabSz="914400" rtl="0" eaLnBrk="1" fontAlgn="auto" latinLnBrk="0" hangingPunct="1">
+              <a:lnSpc>
+                <a:spcPct val="100000"/>
+              </a:lnSpc>
+              <a:spcBef>
+                <a:spcPts val="0"/>
+              </a:spcBef>
+              <a:spcAft>
+                <a:spcPts val="0"/>
+              </a:spcAft>
+              <a:buClrTx/>
+              <a:buSzTx/>
+              <a:buFontTx/>
+              <a:buNone/>
+              <a:tabLst/>
+              <a:defRPr/>
+            </a:pPr>
+            <a:fld id="{F7021451-1387-4CA6-816F-3879F97B5CBC}" type="slidenum">
+              <a:rPr kumimoji="0" lang="en-US" sz="1800" b="0" i="0" u="none" strike="noStrike" kern="1200" cap="none" spc="0" normalizeH="0" baseline="0" noProof="0">
+                <a:ln>
+                  <a:noFill/>
+                </a:ln>
+                <a:solidFill>
+                  <a:prstClr val="black"/>
+                </a:solidFill>
+                <a:effectLst/>
+                <a:uLnTx/>
+                <a:uFillTx/>
+                <a:latin typeface="Aptos" panose="02110004020202020204"/>
+                <a:ea typeface="+mn-ea"/>
+                <a:cs typeface="+mn-cs"/>
+              </a:rPr>
+              <a:pPr marL="0" marR="0" lvl="0" indent="0" algn="l" defTabSz="914400" rtl="0" eaLnBrk="1" fontAlgn="auto" latinLnBrk="0" hangingPunct="1">
+                <a:lnSpc>
+                  <a:spcPct val="100000"/>
+                </a:lnSpc>
+                <a:spcBef>
+                  <a:spcPts val="0"/>
+                </a:spcBef>
+                <a:spcAft>
+                  <a:spcPts val="0"/>
+                </a:spcAft>
+                <a:buClrTx/>
+                <a:buSzTx/>
+                <a:buFontTx/>
+                <a:buNone/>
+                <a:tabLst/>
+                <a:defRPr/>
+              </a:pPr>
+              <a:t>7</a:t>
+            </a:fld>
+            <a:endParaRPr kumimoji="0" lang="en-US" sz="1800" b="0" i="0" u="none" strike="noStrike" kern="1200" cap="none" spc="0" normalizeH="0" baseline="0" noProof="0">
+              <a:ln>
+                <a:noFill/>
+              </a:ln>
+              <a:solidFill>
+                <a:prstClr val="black"/>
+              </a:solidFill>
+              <a:effectLst/>
+              <a:uLnTx/>
+              <a:uFillTx/>
+              <a:latin typeface="Aptos" panose="02110004020202020204"/>
+              <a:ea typeface="+mn-ea"/>
+              <a:cs typeface="+mn-cs"/>
+            </a:endParaRPr>
+          </a:p>
+        </p:txBody>
+      </p:sp>
+    </p:spTree>
+    <p:extLst>
+      <p:ext uri="{BB962C8B-B14F-4D97-AF65-F5344CB8AC3E}">
+        <p14:creationId xmlns:p14="http://schemas.microsoft.com/office/powerpoint/2010/main" val="1024086991"/>
+      </p:ext>
+    </p:extLst>
+  </p:cSld>
+  <p:clrMapOvr>
+    <a:masterClrMapping/>
+  </p:clrMapOvr>
+</p:notes>
+</file>
+
 <file path=ppt/slideLayouts/slideLayout1.xml><?xml version="1.0" encoding="utf-8"?>
 <p:sldLayout xmlns:a="http://schemas.openxmlformats.org/drawingml/2006/main" xmlns:r="http://schemas.openxmlformats.org/officeDocument/2006/relationships" xmlns:p="http://schemas.openxmlformats.org/presentationml/2006/main" preserve="1">
   <p:cSld name="DEFAULT">
@@ -769,6 +915,79 @@
         </a:xfrm>
       </p:grpSpPr>
     </p:spTree>
+  </p:cSld>
+  <p:clrMapOvr>
+    <a:masterClrMapping/>
+  </p:clrMapOvr>
+</p:sldLayout>
+</file>
+
+<file path=ppt/slideLayouts/slideLayout2.xml><?xml version="1.0" encoding="utf-8"?>
+<p:sldLayout xmlns:a="http://schemas.openxmlformats.org/drawingml/2006/main" xmlns:r="http://schemas.openxmlformats.org/officeDocument/2006/relationships" xmlns:p="http://schemas.openxmlformats.org/presentationml/2006/main" preserve="1">
+  <p:cSld name="DEFAULT">
+    <p:bg>
+      <p:bgRef idx="1001">
+        <a:schemeClr val="bg1"/>
+      </p:bgRef>
+    </p:bg>
+    <p:spTree>
+      <p:nvGrpSpPr>
+        <p:cNvPr id="1" name=""/>
+        <p:cNvGrpSpPr/>
+        <p:nvPr/>
+      </p:nvGrpSpPr>
+      <p:grpSpPr>
+        <a:xfrm>
+          <a:off x="0" y="0"/>
+          <a:ext cx="0" cy="0"/>
+          <a:chOff x="0" y="0"/>
+          <a:chExt cx="0" cy="0"/>
+        </a:xfrm>
+      </p:grpSpPr>
+    </p:spTree>
+    <p:extLst>
+      <p:ext uri="{BB962C8B-B14F-4D97-AF65-F5344CB8AC3E}">
+        <p14:creationId xmlns:p14="http://schemas.microsoft.com/office/powerpoint/2010/main" val="2457689242"/>
+      </p:ext>
+    </p:extLst>
+  </p:cSld>
+  <p:clrMapOvr>
+    <a:masterClrMapping/>
+  </p:clrMapOvr>
+</p:sldLayout>
+</file>
+
+<file path=ppt/slideLayouts/slideLayout3.xml><?xml version="1.0" encoding="utf-8"?>
+<p:sldLayout xmlns:a="http://schemas.openxmlformats.org/drawingml/2006/main" xmlns:r="http://schemas.openxmlformats.org/officeDocument/2006/relationships" xmlns:p="http://schemas.openxmlformats.org/presentationml/2006/main" preserve="1">
+  <p:cSld name="DARK">
+    <p:bg>
+      <p:bgPr>
+        <a:solidFill>
+          <a:srgbClr val="070B12"/>
+        </a:solidFill>
+        <a:effectLst/>
+      </p:bgPr>
+    </p:bg>
+    <p:spTree>
+      <p:nvGrpSpPr>
+        <p:cNvPr id="1" name=""/>
+        <p:cNvGrpSpPr/>
+        <p:nvPr/>
+      </p:nvGrpSpPr>
+      <p:grpSpPr>
+        <a:xfrm>
+          <a:off x="0" y="0"/>
+          <a:ext cx="0" cy="0"/>
+          <a:chOff x="0" y="0"/>
+          <a:chExt cx="0" cy="0"/>
+        </a:xfrm>
+      </p:grpSpPr>
+    </p:spTree>
+    <p:extLst>
+      <p:ext uri="{BB962C8B-B14F-4D97-AF65-F5344CB8AC3E}">
+        <p14:creationId xmlns:p14="http://schemas.microsoft.com/office/powerpoint/2010/main" val="327562253"/>
+      </p:ext>
+    </p:extLst>
   </p:cSld>
   <p:clrMapOvr>
     <a:masterClrMapping/>
@@ -1058,6 +1277,294 @@
 </p:sldMaster>
 </file>
 
+<file path=ppt/slideMasters/slideMaster2.xml><?xml version="1.0" encoding="utf-8"?>
+<p:sldMaster xmlns:a="http://schemas.openxmlformats.org/drawingml/2006/main" xmlns:r="http://schemas.openxmlformats.org/officeDocument/2006/relationships" xmlns:p="http://schemas.openxmlformats.org/presentationml/2006/main">
+  <p:cSld>
+    <p:bg>
+      <p:bgRef idx="1001">
+        <a:schemeClr val="bg1"/>
+      </p:bgRef>
+    </p:bg>
+    <p:spTree>
+      <p:nvGrpSpPr>
+        <p:cNvPr id="1" name=""/>
+        <p:cNvGrpSpPr/>
+        <p:nvPr/>
+      </p:nvGrpSpPr>
+      <p:grpSpPr>
+        <a:xfrm>
+          <a:off x="0" y="0"/>
+          <a:ext cx="0" cy="0"/>
+          <a:chOff x="0" y="0"/>
+          <a:chExt cx="0" cy="0"/>
+        </a:xfrm>
+      </p:grpSpPr>
+    </p:spTree>
+    <p:extLst>
+      <p:ext uri="{BB962C8B-B14F-4D97-AF65-F5344CB8AC3E}">
+        <p14:creationId xmlns:p14="http://schemas.microsoft.com/office/powerpoint/2010/main" val="1150819804"/>
+      </p:ext>
+    </p:extLst>
+  </p:cSld>
+  <p:clrMap bg1="lt1" tx1="dk1" bg2="lt2" tx2="dk2" accent1="accent1" accent2="accent2" accent3="accent3" accent4="accent4" accent5="accent5" accent6="accent6" hlink="hlink" folHlink="folHlink"/>
+  <p:sldLayoutIdLst>
+    <p:sldLayoutId id="2147483651" r:id="rId1"/>
+    <p:sldLayoutId id="2147483652" r:id="rId2"/>
+  </p:sldLayoutIdLst>
+  <p:hf sldNum="0" hdr="0" ftr="0" dt="0"/>
+  <p:txStyles>
+    <p:titleStyle>
+      <a:lvl1pPr algn="ctr" defTabSz="685800" rtl="0" eaLnBrk="1" latinLnBrk="0" hangingPunct="1">
+        <a:spcBef>
+          <a:spcPct val="0"/>
+        </a:spcBef>
+        <a:buNone/>
+        <a:defRPr sz="3300" kern="1200">
+          <a:solidFill>
+            <a:schemeClr val="tx1"/>
+          </a:solidFill>
+          <a:latin typeface="+mj-lt"/>
+          <a:ea typeface="+mj-ea"/>
+          <a:cs typeface="+mj-cs"/>
+        </a:defRPr>
+      </a:lvl1pPr>
+    </p:titleStyle>
+    <p:bodyStyle>
+      <a:lvl1pPr marL="257175" indent="-257175" algn="l" defTabSz="685800" rtl="0" eaLnBrk="1" latinLnBrk="0" hangingPunct="1">
+        <a:spcBef>
+          <a:spcPct val="20000"/>
+        </a:spcBef>
+        <a:buFont typeface="Arial" pitchFamily="34" charset="0"/>
+        <a:buChar char="•"/>
+        <a:defRPr sz="2400" kern="1200">
+          <a:solidFill>
+            <a:schemeClr val="tx1"/>
+          </a:solidFill>
+          <a:latin typeface="+mn-lt"/>
+          <a:ea typeface="+mn-ea"/>
+          <a:cs typeface="+mn-cs"/>
+        </a:defRPr>
+      </a:lvl1pPr>
+      <a:lvl2pPr marL="557213" indent="-214313" algn="l" defTabSz="685800" rtl="0" eaLnBrk="1" latinLnBrk="0" hangingPunct="1">
+        <a:spcBef>
+          <a:spcPct val="20000"/>
+        </a:spcBef>
+        <a:buFont typeface="Arial" pitchFamily="34" charset="0"/>
+        <a:buChar char="–"/>
+        <a:defRPr sz="2100" kern="1200">
+          <a:solidFill>
+            <a:schemeClr val="tx1"/>
+          </a:solidFill>
+          <a:latin typeface="+mn-lt"/>
+          <a:ea typeface="+mn-ea"/>
+          <a:cs typeface="+mn-cs"/>
+        </a:defRPr>
+      </a:lvl2pPr>
+      <a:lvl3pPr marL="857250" indent="-171450" algn="l" defTabSz="685800" rtl="0" eaLnBrk="1" latinLnBrk="0" hangingPunct="1">
+        <a:spcBef>
+          <a:spcPct val="20000"/>
+        </a:spcBef>
+        <a:buFont typeface="Arial" pitchFamily="34" charset="0"/>
+        <a:buChar char="•"/>
+        <a:defRPr sz="1800" kern="1200">
+          <a:solidFill>
+            <a:schemeClr val="tx1"/>
+          </a:solidFill>
+          <a:latin typeface="+mn-lt"/>
+          <a:ea typeface="+mn-ea"/>
+          <a:cs typeface="+mn-cs"/>
+        </a:defRPr>
+      </a:lvl3pPr>
+      <a:lvl4pPr marL="1200150" indent="-171450" algn="l" defTabSz="685800" rtl="0" eaLnBrk="1" latinLnBrk="0" hangingPunct="1">
+        <a:spcBef>
+          <a:spcPct val="20000"/>
+        </a:spcBef>
+        <a:buFont typeface="Arial" pitchFamily="34" charset="0"/>
+        <a:buChar char="–"/>
+        <a:defRPr sz="1500" kern="1200">
+          <a:solidFill>
+            <a:schemeClr val="tx1"/>
+          </a:solidFill>
+          <a:latin typeface="+mn-lt"/>
+          <a:ea typeface="+mn-ea"/>
+          <a:cs typeface="+mn-cs"/>
+        </a:defRPr>
+      </a:lvl4pPr>
+      <a:lvl5pPr marL="1543050" indent="-171450" algn="l" defTabSz="685800" rtl="0" eaLnBrk="1" latinLnBrk="0" hangingPunct="1">
+        <a:spcBef>
+          <a:spcPct val="20000"/>
+        </a:spcBef>
+        <a:buFont typeface="Arial" pitchFamily="34" charset="0"/>
+        <a:buChar char="»"/>
+        <a:defRPr sz="1500" kern="1200">
+          <a:solidFill>
+            <a:schemeClr val="tx1"/>
+          </a:solidFill>
+          <a:latin typeface="+mn-lt"/>
+          <a:ea typeface="+mn-ea"/>
+          <a:cs typeface="+mn-cs"/>
+        </a:defRPr>
+      </a:lvl5pPr>
+      <a:lvl6pPr marL="1885950" indent="-171450" algn="l" defTabSz="685800" rtl="0" eaLnBrk="1" latinLnBrk="0" hangingPunct="1">
+        <a:spcBef>
+          <a:spcPct val="20000"/>
+        </a:spcBef>
+        <a:buFont typeface="Arial" pitchFamily="34" charset="0"/>
+        <a:buChar char="•"/>
+        <a:defRPr sz="1500" kern="1200">
+          <a:solidFill>
+            <a:schemeClr val="tx1"/>
+          </a:solidFill>
+          <a:latin typeface="+mn-lt"/>
+          <a:ea typeface="+mn-ea"/>
+          <a:cs typeface="+mn-cs"/>
+        </a:defRPr>
+      </a:lvl6pPr>
+      <a:lvl7pPr marL="2228850" indent="-171450" algn="l" defTabSz="685800" rtl="0" eaLnBrk="1" latinLnBrk="0" hangingPunct="1">
+        <a:spcBef>
+          <a:spcPct val="20000"/>
+        </a:spcBef>
+        <a:buFont typeface="Arial" pitchFamily="34" charset="0"/>
+        <a:buChar char="•"/>
+        <a:defRPr sz="1500" kern="1200">
+          <a:solidFill>
+            <a:schemeClr val="tx1"/>
+          </a:solidFill>
+          <a:latin typeface="+mn-lt"/>
+          <a:ea typeface="+mn-ea"/>
+          <a:cs typeface="+mn-cs"/>
+        </a:defRPr>
+      </a:lvl7pPr>
+      <a:lvl8pPr marL="2571750" indent="-171450" algn="l" defTabSz="685800" rtl="0" eaLnBrk="1" latinLnBrk="0" hangingPunct="1">
+        <a:spcBef>
+          <a:spcPct val="20000"/>
+        </a:spcBef>
+        <a:buFont typeface="Arial" pitchFamily="34" charset="0"/>
+        <a:buChar char="•"/>
+        <a:defRPr sz="1500" kern="1200">
+          <a:solidFill>
+            <a:schemeClr val="tx1"/>
+          </a:solidFill>
+          <a:latin typeface="+mn-lt"/>
+          <a:ea typeface="+mn-ea"/>
+          <a:cs typeface="+mn-cs"/>
+        </a:defRPr>
+      </a:lvl8pPr>
+      <a:lvl9pPr marL="2914650" indent="-171450" algn="l" defTabSz="685800" rtl="0" eaLnBrk="1" latinLnBrk="0" hangingPunct="1">
+        <a:spcBef>
+          <a:spcPct val="20000"/>
+        </a:spcBef>
+        <a:buFont typeface="Arial" pitchFamily="34" charset="0"/>
+        <a:buChar char="•"/>
+        <a:defRPr sz="1500" kern="1200">
+          <a:solidFill>
+            <a:schemeClr val="tx1"/>
+          </a:solidFill>
+          <a:latin typeface="+mn-lt"/>
+          <a:ea typeface="+mn-ea"/>
+          <a:cs typeface="+mn-cs"/>
+        </a:defRPr>
+      </a:lvl9pPr>
+    </p:bodyStyle>
+    <p:otherStyle>
+      <a:defPPr>
+        <a:defRPr lang="en-US"/>
+      </a:defPPr>
+      <a:lvl1pPr marL="0" algn="l" defTabSz="685800" rtl="0" eaLnBrk="1" latinLnBrk="0" hangingPunct="1">
+        <a:defRPr sz="1350" kern="1200">
+          <a:solidFill>
+            <a:schemeClr val="tx1"/>
+          </a:solidFill>
+          <a:latin typeface="+mn-lt"/>
+          <a:ea typeface="+mn-ea"/>
+          <a:cs typeface="+mn-cs"/>
+        </a:defRPr>
+      </a:lvl1pPr>
+      <a:lvl2pPr marL="342900" algn="l" defTabSz="685800" rtl="0" eaLnBrk="1" latinLnBrk="0" hangingPunct="1">
+        <a:defRPr sz="1350" kern="1200">
+          <a:solidFill>
+            <a:schemeClr val="tx1"/>
+          </a:solidFill>
+          <a:latin typeface="+mn-lt"/>
+          <a:ea typeface="+mn-ea"/>
+          <a:cs typeface="+mn-cs"/>
+        </a:defRPr>
+      </a:lvl2pPr>
+      <a:lvl3pPr marL="685800" algn="l" defTabSz="685800" rtl="0" eaLnBrk="1" latinLnBrk="0" hangingPunct="1">
+        <a:defRPr sz="1350" kern="1200">
+          <a:solidFill>
+            <a:schemeClr val="tx1"/>
+          </a:solidFill>
+          <a:latin typeface="+mn-lt"/>
+          <a:ea typeface="+mn-ea"/>
+          <a:cs typeface="+mn-cs"/>
+        </a:defRPr>
+      </a:lvl3pPr>
+      <a:lvl4pPr marL="1028700" algn="l" defTabSz="685800" rtl="0" eaLnBrk="1" latinLnBrk="0" hangingPunct="1">
+        <a:defRPr sz="1350" kern="1200">
+          <a:solidFill>
+            <a:schemeClr val="tx1"/>
+          </a:solidFill>
+          <a:latin typeface="+mn-lt"/>
+          <a:ea typeface="+mn-ea"/>
+          <a:cs typeface="+mn-cs"/>
+        </a:defRPr>
+      </a:lvl4pPr>
+      <a:lvl5pPr marL="1371600" algn="l" defTabSz="685800" rtl="0" eaLnBrk="1" latinLnBrk="0" hangingPunct="1">
+        <a:defRPr sz="1350" kern="1200">
+          <a:solidFill>
+            <a:schemeClr val="tx1"/>
+          </a:solidFill>
+          <a:latin typeface="+mn-lt"/>
+          <a:ea typeface="+mn-ea"/>
+          <a:cs typeface="+mn-cs"/>
+        </a:defRPr>
+      </a:lvl5pPr>
+      <a:lvl6pPr marL="1714500" algn="l" defTabSz="685800" rtl="0" eaLnBrk="1" latinLnBrk="0" hangingPunct="1">
+        <a:defRPr sz="1350" kern="1200">
+          <a:solidFill>
+            <a:schemeClr val="tx1"/>
+          </a:solidFill>
+          <a:latin typeface="+mn-lt"/>
+          <a:ea typeface="+mn-ea"/>
+          <a:cs typeface="+mn-cs"/>
+        </a:defRPr>
+      </a:lvl6pPr>
+      <a:lvl7pPr marL="2057400" algn="l" defTabSz="685800" rtl="0" eaLnBrk="1" latinLnBrk="0" hangingPunct="1">
+        <a:defRPr sz="1350" kern="1200">
+          <a:solidFill>
+            <a:schemeClr val="tx1"/>
+          </a:solidFill>
+          <a:latin typeface="+mn-lt"/>
+          <a:ea typeface="+mn-ea"/>
+          <a:cs typeface="+mn-cs"/>
+        </a:defRPr>
+      </a:lvl7pPr>
+      <a:lvl8pPr marL="2400300" algn="l" defTabSz="685800" rtl="0" eaLnBrk="1" latinLnBrk="0" hangingPunct="1">
+        <a:defRPr sz="1350" kern="1200">
+          <a:solidFill>
+            <a:schemeClr val="tx1"/>
+          </a:solidFill>
+          <a:latin typeface="+mn-lt"/>
+          <a:ea typeface="+mn-ea"/>
+          <a:cs typeface="+mn-cs"/>
+        </a:defRPr>
+      </a:lvl8pPr>
+      <a:lvl9pPr marL="2743200" algn="l" defTabSz="685800" rtl="0" eaLnBrk="1" latinLnBrk="0" hangingPunct="1">
+        <a:defRPr sz="1350" kern="1200">
+          <a:solidFill>
+            <a:schemeClr val="tx1"/>
+          </a:solidFill>
+          <a:latin typeface="+mn-lt"/>
+          <a:ea typeface="+mn-ea"/>
+          <a:cs typeface="+mn-cs"/>
+        </a:defRPr>
+      </a:lvl9pPr>
+    </p:otherStyle>
+  </p:txStyles>
+</p:sldMaster>
+</file>
+
 <file path=ppt/slides/slide1.xml><?xml version="1.0" encoding="utf-8"?>
 <p:sld xmlns:a="http://schemas.openxmlformats.org/drawingml/2006/main" xmlns:r="http://schemas.openxmlformats.org/officeDocument/2006/relationships" xmlns:p="http://schemas.openxmlformats.org/presentationml/2006/main">
   <p:cSld name="Slide 1">
@@ -1155,7 +1662,7 @@
                 <a:ea typeface="Calibri" pitchFamily="34" charset="-122"/>
                 <a:cs typeface="Calibri" pitchFamily="34" charset="-120"/>
               </a:rPr>
-              <a:t>About me   ·   1 / 6</a:t>
+              <a:t>About me   ·   1 / 7</a:t>
             </a:r>
             <a:endParaRPr lang="en-US" sz="900" dirty="0"/>
           </a:p>
@@ -1301,9 +1808,6 @@
             <a:endParaRPr lang="en-US" sz="1400" dirty="0"/>
           </a:p>
           <a:p>
-            <a:pPr marL="0" indent="0">
-              <a:buNone/>
-            </a:pPr>
             <a:r>
               <a:rPr lang="en-US" sz="1400" dirty="0">
                 <a:solidFill>
@@ -1313,9 +1817,8 @@
                 <a:ea typeface="Calibri" pitchFamily="34" charset="-122"/>
                 <a:cs typeface="Calibri" pitchFamily="34" charset="-120"/>
               </a:rPr>
-              <a:t>888 Holdings (Evoke) · regulated online gaming platforms</a:t>
-            </a:r>
-            <a:endParaRPr lang="en-US" sz="1400" dirty="0"/>
+              <a:t>888 Holdings (Evoke) · regulated multi-jurisdiction production environments</a:t>
+            </a:r>
           </a:p>
         </p:txBody>
       </p:sp>
@@ -1341,6 +1844,17 @@
           <a:lstStyle/>
           <a:p>
             <a:r>
+              <a:rPr lang="en-US" sz="1300" b="1" i="1" dirty="0">
+                <a:solidFill>
+                  <a:srgbClr val="9FB0CC"/>
+                </a:solidFill>
+                <a:latin typeface="Calibri" pitchFamily="34" charset="0"/>
+                <a:ea typeface="Calibri" pitchFamily="34" charset="-122"/>
+                <a:cs typeface="Calibri" pitchFamily="34" charset="-120"/>
+              </a:rPr>
+              <a:t>Software engineer with 2+ years in production operations. </a:t>
+            </a:r>
+            <a:r>
               <a:rPr lang="en-US" sz="1300" i="1" dirty="0">
                 <a:solidFill>
                   <a:srgbClr val="9FB0CC"/>
@@ -1349,14 +1863,8 @@
                 <a:ea typeface="Calibri" pitchFamily="34" charset="-122"/>
                 <a:cs typeface="Calibri" pitchFamily="34" charset="-120"/>
               </a:rPr>
-              <a:t>I turn daily operational pain into software. automating workflows, optimizing internal tooling, and shipping multi-agent systems with n8n and Claude Code.</a:t>
-            </a:r>
-          </a:p>
-          <a:p>
-            <a:pPr marL="0" indent="0">
-              <a:buNone/>
-            </a:pPr>
-            <a:endParaRPr lang="en-US" sz="1300" dirty="0"/>
+              <a:t>I turn daily operational pain into software: automating workflows, optimizing internal tooling, and shipping multi-agent systems with n8n and Claude Code.</a:t>
+            </a:r>
           </a:p>
         </p:txBody>
       </p:sp>
@@ -1628,7 +2136,7 @@
                 <a:ea typeface="Calibri" pitchFamily="34" charset="-122"/>
                 <a:cs typeface="Calibri" pitchFamily="34" charset="-120"/>
               </a:rPr>
-              <a:t>The Open University - B.Sc. Computer Science</a:t>
+              <a:t>The Open University - B.Sc. Computer Science – GPA 91</a:t>
             </a:r>
             <a:endParaRPr lang="en-US" sz="1050" dirty="0"/>
           </a:p>
@@ -1727,7 +2235,7 @@
                 <a:ea typeface="Calibri" pitchFamily="34" charset="-122"/>
                 <a:cs typeface="Calibri" pitchFamily="34" charset="-120"/>
               </a:rPr>
-              <a:t>Production database infrastructure across NJ-DGE, database and infrastructure operations across regulated, multi-jurisdiction environments</a:t>
+              <a:t>2+ years operating production databases and infrastructure across regulated, multi-jurisdiction environments</a:t>
             </a:r>
           </a:p>
           <a:p>
@@ -2047,7 +2555,7 @@
                 <a:ea typeface="Calibri" pitchFamily="34" charset="-122"/>
                 <a:cs typeface="Calibri" pitchFamily="34" charset="-120"/>
               </a:rPr>
-              <a:t>Project overview   ·   2 / 6</a:t>
+              <a:t>Project overview   ·   2 / 7</a:t>
             </a:r>
             <a:endParaRPr lang="en-US" sz="900" dirty="0"/>
           </a:p>
@@ -2957,7 +3465,7 @@
                 <a:ea typeface="Calibri" pitchFamily="34" charset="-122"/>
                 <a:cs typeface="Calibri" pitchFamily="34" charset="-120"/>
               </a:rPr>
-              <a:t>Technologies   ·   3 / 6</a:t>
+              <a:t>Technologies   ·   3 / 7</a:t>
             </a:r>
             <a:endParaRPr lang="en-US" sz="900" dirty="0"/>
           </a:p>
@@ -3848,7 +4356,7 @@
                 <a:ea typeface="Calibri" pitchFamily="34" charset="-122"/>
                 <a:cs typeface="Calibri" pitchFamily="34" charset="-120"/>
               </a:rPr>
-              <a:t>Guarded escalation — preview-before-send P1 alerts via SMS + email — preview-before-send</a:t>
+              <a:t>Guarded escalation - preview-before-send P1 alerts via SMS + email.</a:t>
             </a:r>
           </a:p>
         </p:txBody>
@@ -3980,51 +4488,7 @@
                 <a:ea typeface="Calibri" pitchFamily="34" charset="-122"/>
                 <a:cs typeface="Calibri" pitchFamily="34" charset="-120"/>
               </a:rPr>
-              <a:t>Synthetic ops dataset. owners, on-call, priority matrix, deploy </a:t>
-            </a:r>
-            <a:r>
-              <a:rPr lang="en-US" sz="1000">
-                <a:solidFill>
-                  <a:srgbClr val="9FB0CC"/>
-                </a:solidFill>
-                <a:latin typeface="Calibri" pitchFamily="34" charset="0"/>
-                <a:ea typeface="Calibri" pitchFamily="34" charset="-122"/>
-                <a:cs typeface="Calibri" pitchFamily="34" charset="-120"/>
-              </a:rPr>
-              <a:t>history </a:t>
-            </a:r>
-            <a:r>
-              <a:rPr lang="en-US" sz="1000" dirty="0">
-                <a:solidFill>
-                  <a:srgbClr val="9FB0CC"/>
-                </a:solidFill>
-                <a:latin typeface="Calibri" pitchFamily="34" charset="0"/>
-                <a:ea typeface="Calibri" pitchFamily="34" charset="-122"/>
-                <a:cs typeface="Calibri" pitchFamily="34" charset="-120"/>
-              </a:rPr>
-              <a:t>-</a:t>
-            </a:r>
-            <a:r>
-              <a:rPr lang="en-US" sz="1000">
-                <a:solidFill>
-                  <a:srgbClr val="9FB0CC"/>
-                </a:solidFill>
-                <a:latin typeface="Calibri" pitchFamily="34" charset="0"/>
-                <a:ea typeface="Calibri" pitchFamily="34" charset="-122"/>
-                <a:cs typeface="Calibri" pitchFamily="34" charset="-120"/>
-              </a:rPr>
-              <a:t> </a:t>
-            </a:r>
-            <a:r>
-              <a:rPr lang="en-US" sz="1000" dirty="0">
-                <a:solidFill>
-                  <a:srgbClr val="9FB0CC"/>
-                </a:solidFill>
-                <a:latin typeface="Calibri" pitchFamily="34" charset="0"/>
-                <a:ea typeface="Calibri" pitchFamily="34" charset="-122"/>
-                <a:cs typeface="Calibri" pitchFamily="34" charset="-120"/>
-              </a:rPr>
-              <a:t>synthetic dataset</a:t>
+              <a:t>Synthetic ops dataset, owners, on-call, priority matrix, deploy history.</a:t>
             </a:r>
           </a:p>
         </p:txBody>
@@ -4406,7 +4870,7 @@
                 <a:ea typeface="Calibri" pitchFamily="34" charset="-122"/>
                 <a:cs typeface="Calibri" pitchFamily="34" charset="-120"/>
               </a:rPr>
-              <a:t>Architecture   ·   4 / 6</a:t>
+              <a:t>Architecture   ·   4 / 7</a:t>
             </a:r>
             <a:endParaRPr lang="en-US" sz="900" dirty="0"/>
           </a:p>
@@ -6407,7 +6871,7 @@
                 <a:ea typeface="Calibri" pitchFamily="34" charset="-122"/>
                 <a:cs typeface="Calibri" pitchFamily="34" charset="-120"/>
               </a:rPr>
-              <a:t>4 Lambda tools</a:t>
+              <a:t>4 Lambda action groups</a:t>
             </a:r>
             <a:endParaRPr lang="en-US" sz="1000" dirty="0"/>
           </a:p>
@@ -6579,7 +7043,7 @@
                 <a:ea typeface="Calibri" pitchFamily="34" charset="-122"/>
                 <a:cs typeface="Calibri" pitchFamily="34" charset="-120"/>
               </a:rPr>
-              <a:t>Escalate · Notify to the on-call · SMS/Email</a:t>
+              <a:t>Escalate · Notify on-call · SMS/Email</a:t>
             </a:r>
           </a:p>
         </p:txBody>
@@ -7171,7 +7635,7 @@
                 <a:ea typeface="Calibri" pitchFamily="34" charset="-122"/>
                 <a:cs typeface="Calibri" pitchFamily="34" charset="-120"/>
               </a:rPr>
-              <a:t>Live demo   ·   5 / 6</a:t>
+              <a:t>Live demo   ·   5 / 7</a:t>
             </a:r>
             <a:endParaRPr lang="en-US" sz="900" dirty="0"/>
           </a:p>
@@ -8126,9 +8590,6 @@
           <a:bodyPr wrap="square" lIns="0" tIns="0" rIns="0" bIns="0" rtlCol="0" anchor="ctr"/>
           <a:lstStyle/>
           <a:p>
-            <a:pPr marL="0" indent="0">
-              <a:buNone/>
-            </a:pPr>
             <a:r>
               <a:rPr lang="en-US" sz="1150" b="1" dirty="0">
                 <a:solidFill>
@@ -8149,9 +8610,8 @@
                 <a:ea typeface="Calibri" pitchFamily="34" charset="-122"/>
                 <a:cs typeface="Calibri" pitchFamily="34" charset="-120"/>
               </a:rPr>
-              <a:t>— SMS/email live fires; structured answer with cause, actions, owner</a:t>
-            </a:r>
-            <a:endParaRPr lang="en-US" sz="1150" dirty="0"/>
+              <a:t>— Live SMS/email fires, structured answer with cause, actions, owner.</a:t>
+            </a:r>
           </a:p>
         </p:txBody>
       </p:sp>
@@ -8750,7 +9210,7 @@
                 <a:ea typeface="Calibri" pitchFamily="34" charset="-122"/>
                 <a:cs typeface="Calibri" pitchFamily="34" charset="-120"/>
               </a:rPr>
-              <a:t>Challenges &amp; next steps   ·   6 / 6</a:t>
+              <a:t>Challenges &amp; next steps   ·   6 / 7</a:t>
             </a:r>
             <a:endParaRPr lang="en-US" sz="900" dirty="0"/>
           </a:p>
@@ -8931,7 +9391,6 @@
               </a:rPr>
               <a:t>End-to-end agent flow: alert → RAG → tools → structured PITER answer</a:t>
             </a:r>
-            <a:endParaRPr lang="en-US" sz="1000" dirty="0"/>
           </a:p>
           <a:p>
             <a:pPr marL="342900" indent="-342900">
@@ -8950,9 +9409,8 @@
                 <a:ea typeface="Calibri" pitchFamily="34" charset="-122"/>
                 <a:cs typeface="Calibri" pitchFamily="34" charset="-120"/>
               </a:rPr>
-              <a:t>Demo correlation: deploy → replication lag → similar past incident</a:t>
-            </a:r>
-            <a:endParaRPr lang="en-US" sz="1000" dirty="0"/>
+              <a:t> Demo correlation: deploy → replication lag → similar past incident Safe</a:t>
+            </a:r>
           </a:p>
           <a:p>
             <a:pPr marL="342900" indent="-342900">
@@ -8973,7 +9431,6 @@
               </a:rPr>
               <a:t>Safe escalation: preview first, real SNS/SES only on P1 confirm</a:t>
             </a:r>
-            <a:endParaRPr lang="en-US" sz="1000" dirty="0"/>
           </a:p>
           <a:p>
             <a:pPr marL="342900" indent="-342900">
@@ -8994,6 +9451,15 @@
               </a:rPr>
               <a:t>Local fallback keeps the system answering without AWS</a:t>
             </a:r>
+          </a:p>
+          <a:p>
+            <a:pPr marL="342900" indent="-342900">
+              <a:spcAft>
+                <a:spcPts val="800"/>
+              </a:spcAft>
+              <a:buSzPct val="100000"/>
+              <a:buChar char="•"/>
+            </a:pPr>
             <a:endParaRPr lang="en-US" sz="1000" dirty="0"/>
           </a:p>
         </p:txBody>
@@ -9132,9 +9598,8 @@
                 <a:ea typeface="Calibri" pitchFamily="34" charset="-122"/>
                 <a:cs typeface="Calibri" pitchFamily="34" charset="-120"/>
               </a:rPr>
-              <a:t>MCP path: AgentCore Gateway vs classic action groups (hard cutoff, fallback plan)</a:t>
-            </a:r>
-            <a:endParaRPr lang="en-US" sz="1000" dirty="0"/>
+              <a:t>MCP path: AgentCore Gateway vs classic action groups </a:t>
+            </a:r>
           </a:p>
           <a:p>
             <a:pPr marL="342900" indent="-342900">
@@ -9153,9 +9618,8 @@
                 <a:ea typeface="Calibri" pitchFamily="34" charset="-122"/>
                 <a:cs typeface="Calibri" pitchFamily="34" charset="-120"/>
               </a:rPr>
-              <a:t>Parsing streamed agent traces into clean UI events</a:t>
-            </a:r>
-            <a:endParaRPr lang="en-US" sz="1000" dirty="0"/>
+              <a:t>Cost control - an idle OpenSearch collection caused unexpected charges. moved to S3 Vectors</a:t>
+            </a:r>
           </a:p>
           <a:p>
             <a:pPr marL="342900" indent="-342900">
@@ -9174,9 +9638,8 @@
                 <a:ea typeface="Calibri" pitchFamily="34" charset="-122"/>
                 <a:cs typeface="Calibri" pitchFamily="34" charset="-120"/>
               </a:rPr>
-              <a:t>Cost control — an idle OpenSearch collection taught an expensive lesson, moved to S3 Vectors</a:t>
-            </a:r>
-            <a:endParaRPr lang="en-US" sz="1000" dirty="0"/>
+              <a:t>KB ingestion: structuring CSV/JSON so retrieval stays precise</a:t>
+            </a:r>
           </a:p>
           <a:p>
             <a:pPr marL="342900" indent="-342900">
@@ -9195,9 +9658,28 @@
                 <a:ea typeface="Calibri" pitchFamily="34" charset="-122"/>
                 <a:cs typeface="Calibri" pitchFamily="34" charset="-120"/>
               </a:rPr>
-              <a:t>KB ingestion: structuring CSV/JSON so retrieval stays precise</a:t>
-            </a:r>
-            <a:endParaRPr lang="en-US" sz="1000" dirty="0"/>
+              <a:t>Guardrails tuning - strict enough to block unsafe actions, loose enough to not reject legitimate incident questions</a:t>
+            </a:r>
+          </a:p>
+          <a:p>
+            <a:pPr marL="342900" indent="-342900">
+              <a:spcAft>
+                <a:spcPts val="800"/>
+              </a:spcAft>
+              <a:buSzPct val="100000"/>
+              <a:buChar char="•"/>
+            </a:pPr>
+            <a:r>
+              <a:rPr lang="en-US" sz="1000" dirty="0">
+                <a:solidFill>
+                  <a:srgbClr val="9FB0CC"/>
+                </a:solidFill>
+                <a:latin typeface="Calibri" pitchFamily="34" charset="0"/>
+                <a:ea typeface="Calibri" pitchFamily="34" charset="-122"/>
+                <a:cs typeface="Calibri" pitchFamily="34" charset="-120"/>
+              </a:rPr>
+              <a:t>Action safety - agent reads and recommends. business impact requires human confirmation</a:t>
+            </a:r>
           </a:p>
         </p:txBody>
       </p:sp>
@@ -9306,8 +9788,8 @@
         </p:nvSpPr>
         <p:spPr>
           <a:xfrm>
-            <a:off x="6291072" y="1645920"/>
-            <a:ext cx="2414016" cy="2606040"/>
+            <a:off x="6291072" y="1615440"/>
+            <a:ext cx="2487168" cy="2715768"/>
           </a:xfrm>
           <a:prstGeom prst="rect">
             <a:avLst/>
@@ -9335,9 +9817,8 @@
                 <a:ea typeface="Calibri" pitchFamily="34" charset="-122"/>
                 <a:cs typeface="Calibri" pitchFamily="34" charset="-120"/>
               </a:rPr>
-              <a:t>Full MCP integration via AgentCore Gateway</a:t>
-            </a:r>
-            <a:endParaRPr lang="en-US" sz="1000" dirty="0"/>
+              <a:t>Multi-agent architecture - specialist agents for triage, investigation, and comms, coordinated by a supervisor agent</a:t>
+            </a:r>
           </a:p>
           <a:p>
             <a:pPr marL="342900" indent="-342900">
@@ -9356,9 +9837,8 @@
                 <a:ea typeface="Calibri" pitchFamily="34" charset="-122"/>
                 <a:cs typeface="Calibri" pitchFamily="34" charset="-120"/>
               </a:rPr>
-              <a:t>Live monitoring feeds instead of simulated alerts</a:t>
-            </a:r>
-            <a:endParaRPr lang="en-US" sz="1000" dirty="0"/>
+              <a:t>Slack-native operations - alerts, PITER answers, and approvals directly in the on-call channel</a:t>
+            </a:r>
           </a:p>
           <a:p>
             <a:pPr marL="342900" indent="-342900">
@@ -9377,9 +9857,8 @@
                 <a:ea typeface="Calibri" pitchFamily="34" charset="-122"/>
                 <a:cs typeface="Calibri" pitchFamily="34" charset="-120"/>
               </a:rPr>
-              <a:t>Auto-remediation runbooks with human approval</a:t>
-            </a:r>
-            <a:endParaRPr lang="en-US" sz="1000" dirty="0"/>
+              <a:t>Jira + Confluence integration - auto-open incident tickets, link runbooks, draft post-mortems into the wiki</a:t>
+            </a:r>
           </a:p>
           <a:p>
             <a:pPr marL="342900" indent="-342900">
@@ -9398,7 +9877,27 @@
                 <a:ea typeface="Calibri" pitchFamily="34" charset="-122"/>
                 <a:cs typeface="Calibri" pitchFamily="34" charset="-120"/>
               </a:rPr>
-              <a:t>Multi-environment awareness across regulated platforms</a:t>
+              <a:t>Customer-impact correlation - match alerts against support complaints to detect customer-facing impact early</a:t>
+            </a:r>
+          </a:p>
+          <a:p>
+            <a:pPr marL="342900" indent="-342900">
+              <a:spcAft>
+                <a:spcPts val="800"/>
+              </a:spcAft>
+              <a:buSzPct val="100000"/>
+              <a:buChar char="•"/>
+            </a:pPr>
+            <a:r>
+              <a:rPr lang="en-US" sz="1000" dirty="0">
+                <a:solidFill>
+                  <a:srgbClr val="9FB0CC"/>
+                </a:solidFill>
+                <a:latin typeface="Calibri" pitchFamily="34" charset="0"/>
+                <a:ea typeface="Calibri" pitchFamily="34" charset="-122"/>
+                <a:cs typeface="Calibri" pitchFamily="34" charset="-120"/>
+              </a:rPr>
+              <a:t>Live monitoring feeds instead of simulated alerts</a:t>
             </a:r>
             <a:endParaRPr lang="en-US" sz="1000" dirty="0"/>
           </a:p>
@@ -9428,29 +9927,748 @@
             <a:pPr marL="0" indent="0" algn="ctr">
               <a:buNone/>
             </a:pPr>
-            <a:r>
-              <a:rPr lang="en-US" sz="1100" b="1" dirty="0">
+            <a:endParaRPr lang="en-US" sz="1100" dirty="0"/>
+          </a:p>
+        </p:txBody>
+      </p:sp>
+    </p:spTree>
+  </p:cSld>
+  <p:clrMapOvr>
+    <a:masterClrMapping/>
+  </p:clrMapOvr>
+</p:sld>
+</file>
+
+<file path=ppt/slides/slide7.xml><?xml version="1.0" encoding="utf-8"?>
+<p:sld xmlns:a="http://schemas.openxmlformats.org/drawingml/2006/main" xmlns:r="http://schemas.openxmlformats.org/officeDocument/2006/relationships" xmlns:p="http://schemas.openxmlformats.org/presentationml/2006/main">
+  <p:cSld>
+    <p:bg>
+      <p:bgPr>
+        <a:solidFill>
+          <a:srgbClr val="070B12"/>
+        </a:solidFill>
+        <a:effectLst/>
+      </p:bgPr>
+    </p:bg>
+    <p:spTree>
+      <p:nvGrpSpPr>
+        <p:cNvPr id="1" name=""/>
+        <p:cNvGrpSpPr/>
+        <p:nvPr/>
+      </p:nvGrpSpPr>
+      <p:grpSpPr>
+        <a:xfrm>
+          <a:off x="0" y="0"/>
+          <a:ext cx="0" cy="0"/>
+          <a:chOff x="0" y="0"/>
+          <a:chExt cx="0" cy="0"/>
+        </a:xfrm>
+      </p:grpSpPr>
+      <p:sp>
+        <p:nvSpPr>
+          <p:cNvPr id="2" name="Shape 0"/>
+          <p:cNvSpPr/>
+          <p:nvPr/>
+        </p:nvSpPr>
+        <p:spPr>
+          <a:xfrm>
+            <a:off x="1" y="0"/>
+            <a:ext cx="9143771" cy="68580"/>
+          </a:xfrm>
+          <a:prstGeom prst="rect">
+            <a:avLst/>
+          </a:prstGeom>
+          <a:solidFill>
+            <a:srgbClr val="22D3EE">
+              <a:alpha val="65000"/>
+            </a:srgbClr>
+          </a:solidFill>
+          <a:ln w="12700">
+            <a:solidFill>
+              <a:srgbClr val="22D3EE">
+                <a:alpha val="0"/>
+              </a:srgbClr>
+            </a:solidFill>
+            <a:prstDash val="solid"/>
+          </a:ln>
+        </p:spPr>
+        <p:txBody>
+          <a:bodyPr/>
+          <a:lstStyle/>
+          <a:p>
+            <a:pPr defTabSz="685800"/>
+            <a:endParaRPr lang="en-US" sz="1600">
+              <a:solidFill>
+                <a:prstClr val="black"/>
+              </a:solidFill>
+              <a:latin typeface="Aptos"/>
+            </a:endParaRPr>
+          </a:p>
+        </p:txBody>
+      </p:sp>
+      <p:sp>
+        <p:nvSpPr>
+          <p:cNvPr id="3" name="Text 1"/>
+          <p:cNvSpPr/>
+          <p:nvPr/>
+        </p:nvSpPr>
+        <p:spPr>
+          <a:xfrm>
+            <a:off x="548640" y="651510"/>
+            <a:ext cx="3086100" cy="480060"/>
+          </a:xfrm>
+          <a:prstGeom prst="rect">
+            <a:avLst/>
+          </a:prstGeom>
+          <a:noFill/>
+          <a:ln/>
+        </p:spPr>
+        <p:txBody>
+          <a:bodyPr wrap="square" lIns="0" tIns="0" rIns="0" bIns="0" rtlCol="0" anchor="ctr"/>
+          <a:lstStyle/>
+          <a:p>
+            <a:pPr defTabSz="685800"/>
+            <a:r>
+              <a:rPr lang="en-US" sz="3200" b="1" dirty="0">
+                <a:solidFill>
+                  <a:srgbClr val="F8FAFC"/>
+                </a:solidFill>
+                <a:latin typeface="Aptos"/>
+              </a:rPr>
+              <a:t>Thank you</a:t>
+            </a:r>
+            <a:endParaRPr lang="en-US" sz="3200" dirty="0">
+              <a:solidFill>
+                <a:prstClr val="black"/>
+              </a:solidFill>
+              <a:latin typeface="Aptos"/>
+            </a:endParaRPr>
+          </a:p>
+        </p:txBody>
+      </p:sp>
+      <p:sp>
+        <p:nvSpPr>
+          <p:cNvPr id="4" name="Text 2"/>
+          <p:cNvSpPr/>
+          <p:nvPr/>
+        </p:nvSpPr>
+        <p:spPr>
+          <a:xfrm>
+            <a:off x="569214" y="1200150"/>
+            <a:ext cx="3086100" cy="192024"/>
+          </a:xfrm>
+          <a:prstGeom prst="rect">
+            <a:avLst/>
+          </a:prstGeom>
+          <a:noFill/>
+          <a:ln/>
+        </p:spPr>
+        <p:txBody>
+          <a:bodyPr wrap="square" lIns="0" tIns="0" rIns="0" bIns="0" rtlCol="0" anchor="ctr"/>
+          <a:lstStyle/>
+          <a:p>
+            <a:pPr defTabSz="685800"/>
+            <a:r>
+              <a:rPr lang="en-US" sz="1050" dirty="0">
+                <a:solidFill>
+                  <a:srgbClr val="A7B4C8"/>
+                </a:solidFill>
+                <a:latin typeface="Aptos"/>
+              </a:rPr>
+              <a:t>I appreciate your time and feedback.</a:t>
+            </a:r>
+            <a:endParaRPr lang="en-US" sz="1050" dirty="0">
+              <a:solidFill>
+                <a:prstClr val="black"/>
+              </a:solidFill>
+              <a:latin typeface="Aptos"/>
+            </a:endParaRPr>
+          </a:p>
+        </p:txBody>
+      </p:sp>
+      <p:sp>
+        <p:nvSpPr>
+          <p:cNvPr id="5" name="Shape 3"/>
+          <p:cNvSpPr/>
+          <p:nvPr/>
+        </p:nvSpPr>
+        <p:spPr>
+          <a:xfrm>
+            <a:off x="582930" y="1680210"/>
+            <a:ext cx="3497580" cy="1748790"/>
+          </a:xfrm>
+          <a:prstGeom prst="roundRect">
+            <a:avLst>
+              <a:gd name="adj" fmla="val 3137"/>
+            </a:avLst>
+          </a:prstGeom>
+          <a:solidFill>
+            <a:srgbClr val="0D1421"/>
+          </a:solidFill>
+          <a:ln w="12700">
+            <a:solidFill>
+              <a:srgbClr val="26364F"/>
+            </a:solidFill>
+            <a:prstDash val="solid"/>
+          </a:ln>
+        </p:spPr>
+        <p:txBody>
+          <a:bodyPr/>
+          <a:lstStyle/>
+          <a:p>
+            <a:pPr defTabSz="685800"/>
+            <a:endParaRPr lang="en-US" sz="1600">
+              <a:solidFill>
+                <a:prstClr val="black"/>
+              </a:solidFill>
+              <a:latin typeface="Aptos"/>
+            </a:endParaRPr>
+          </a:p>
+        </p:txBody>
+      </p:sp>
+      <p:sp>
+        <p:nvSpPr>
+          <p:cNvPr id="6" name="Text 4"/>
+          <p:cNvSpPr/>
+          <p:nvPr/>
+        </p:nvSpPr>
+        <p:spPr>
+          <a:xfrm>
+            <a:off x="822960" y="1885950"/>
+            <a:ext cx="2400300" cy="205740"/>
+          </a:xfrm>
+          <a:prstGeom prst="rect">
+            <a:avLst/>
+          </a:prstGeom>
+          <a:noFill/>
+          <a:ln/>
+        </p:spPr>
+        <p:txBody>
+          <a:bodyPr wrap="square" lIns="0" tIns="0" rIns="0" bIns="0" rtlCol="0" anchor="ctr"/>
+          <a:lstStyle/>
+          <a:p>
+            <a:pPr defTabSz="685800"/>
+            <a:r>
+              <a:rPr lang="en-US" b="1" dirty="0">
                 <a:solidFill>
                   <a:srgbClr val="22D3EE"/>
                 </a:solidFill>
-                <a:latin typeface="Calibri" pitchFamily="34" charset="0"/>
-                <a:ea typeface="Calibri" pitchFamily="34" charset="-122"/>
-                <a:cs typeface="Calibri" pitchFamily="34" charset="-120"/>
-              </a:rPr>
-              <a:t>github.com/reem-mor/amdocs-ai-course</a:t>
-            </a:r>
-            <a:r>
-              <a:rPr lang="en-US" sz="1100" dirty="0">
-                <a:solidFill>
-                  <a:srgbClr val="8A97B3"/>
-                </a:solidFill>
-                <a:latin typeface="Calibri" pitchFamily="34" charset="0"/>
-                <a:ea typeface="Calibri" pitchFamily="34" charset="-122"/>
-                <a:cs typeface="Calibri" pitchFamily="34" charset="-120"/>
-              </a:rPr>
-              <a:t>   ·   branch incidentIQ-midproject   ·   thank you!</a:t>
-            </a:r>
-            <a:endParaRPr lang="en-US" sz="1100" dirty="0"/>
+                <a:latin typeface="Aptos"/>
+              </a:rPr>
+              <a:t>PITER AiOps</a:t>
+            </a:r>
+            <a:endParaRPr lang="en-US" dirty="0">
+              <a:solidFill>
+                <a:prstClr val="black"/>
+              </a:solidFill>
+              <a:latin typeface="Aptos"/>
+            </a:endParaRPr>
+          </a:p>
+        </p:txBody>
+      </p:sp>
+      <p:sp>
+        <p:nvSpPr>
+          <p:cNvPr id="7" name="Text 5"/>
+          <p:cNvSpPr/>
+          <p:nvPr/>
+        </p:nvSpPr>
+        <p:spPr>
+          <a:xfrm>
+            <a:off x="822960" y="2208276"/>
+            <a:ext cx="2811780" cy="109728"/>
+          </a:xfrm>
+          <a:prstGeom prst="rect">
+            <a:avLst/>
+          </a:prstGeom>
+          <a:noFill/>
+          <a:ln/>
+        </p:spPr>
+        <p:txBody>
+          <a:bodyPr wrap="square" lIns="0" tIns="0" rIns="0" bIns="0" rtlCol="0" anchor="ctr">
+            <a:noAutofit/>
+          </a:bodyPr>
+          <a:lstStyle/>
+          <a:p>
+            <a:pPr defTabSz="685800"/>
+            <a:r>
+              <a:rPr lang="en-US" sz="800" dirty="0">
+                <a:solidFill>
+                  <a:srgbClr val="A7B4C8"/>
+                </a:solidFill>
+                <a:latin typeface="Aptos"/>
+              </a:rPr>
+              <a:t>Priority  |  Investigation  |  Triage  |  Escalation  |  Resolution</a:t>
+            </a:r>
+            <a:endParaRPr lang="en-US" sz="800" dirty="0">
+              <a:solidFill>
+                <a:prstClr val="black"/>
+              </a:solidFill>
+              <a:latin typeface="Aptos"/>
+            </a:endParaRPr>
+          </a:p>
+        </p:txBody>
+      </p:sp>
+      <p:sp>
+        <p:nvSpPr>
+          <p:cNvPr id="8" name="Text 6"/>
+          <p:cNvSpPr/>
+          <p:nvPr/>
+        </p:nvSpPr>
+        <p:spPr>
+          <a:xfrm>
+            <a:off x="822960" y="2551176"/>
+            <a:ext cx="2743200" cy="226314"/>
+          </a:xfrm>
+          <a:prstGeom prst="rect">
+            <a:avLst/>
+          </a:prstGeom>
+          <a:noFill/>
+          <a:ln/>
+        </p:spPr>
+        <p:txBody>
+          <a:bodyPr wrap="square" lIns="0" tIns="0" rIns="0" bIns="0" rtlCol="0" anchor="ctr">
+            <a:noAutofit/>
+          </a:bodyPr>
+          <a:lstStyle/>
+          <a:p>
+            <a:pPr defTabSz="685800"/>
+            <a:r>
+              <a:rPr lang="en-US" sz="1000" dirty="0">
+                <a:solidFill>
+                  <a:srgbClr val="F8FAFC"/>
+                </a:solidFill>
+                <a:latin typeface="Aptos"/>
+              </a:rPr>
+              <a:t>Live demo repo, LinkedIn and contact details are on the right.</a:t>
+            </a:r>
+            <a:endParaRPr lang="en-US" sz="1000" dirty="0">
+              <a:solidFill>
+                <a:prstClr val="black"/>
+              </a:solidFill>
+              <a:latin typeface="Aptos"/>
+            </a:endParaRPr>
+          </a:p>
+        </p:txBody>
+      </p:sp>
+      <p:sp>
+        <p:nvSpPr>
+          <p:cNvPr id="9" name="Text 7"/>
+          <p:cNvSpPr/>
+          <p:nvPr/>
+        </p:nvSpPr>
+        <p:spPr>
+          <a:xfrm>
+            <a:off x="822960" y="2983230"/>
+            <a:ext cx="2880360" cy="288036"/>
+          </a:xfrm>
+          <a:prstGeom prst="rect">
+            <a:avLst/>
+          </a:prstGeom>
+          <a:noFill/>
+          <a:ln/>
+        </p:spPr>
+        <p:txBody>
+          <a:bodyPr wrap="square" lIns="0" tIns="0" rIns="0" bIns="0" rtlCol="0" anchor="ctr">
+            <a:noAutofit/>
+          </a:bodyPr>
+          <a:lstStyle/>
+          <a:p>
+            <a:pPr defTabSz="685800"/>
+            <a:r>
+              <a:rPr lang="en-US" sz="800" dirty="0">
+                <a:solidFill>
+                  <a:srgbClr val="A7B4C8"/>
+                </a:solidFill>
+                <a:latin typeface="Aptos"/>
+              </a:rPr>
+              <a:t>Email: reem.mor3@gmail.com</a:t>
+            </a:r>
+            <a:endParaRPr lang="en-US" sz="800" dirty="0">
+              <a:solidFill>
+                <a:prstClr val="black"/>
+              </a:solidFill>
+              <a:latin typeface="Aptos"/>
+            </a:endParaRPr>
+          </a:p>
+        </p:txBody>
+      </p:sp>
+      <p:sp>
+        <p:nvSpPr>
+          <p:cNvPr id="10" name="Shape 8"/>
+          <p:cNvSpPr/>
+          <p:nvPr/>
+        </p:nvSpPr>
+        <p:spPr>
+          <a:xfrm>
+            <a:off x="4526280" y="1508760"/>
+            <a:ext cx="1508760" cy="1748790"/>
+          </a:xfrm>
+          <a:prstGeom prst="roundRect">
+            <a:avLst>
+              <a:gd name="adj" fmla="val 3636"/>
+            </a:avLst>
+          </a:prstGeom>
+          <a:solidFill>
+            <a:srgbClr val="0D1421"/>
+          </a:solidFill>
+          <a:ln w="12700">
+            <a:solidFill>
+              <a:srgbClr val="26364F"/>
+            </a:solidFill>
+            <a:prstDash val="solid"/>
+          </a:ln>
+        </p:spPr>
+        <p:txBody>
+          <a:bodyPr/>
+          <a:lstStyle/>
+          <a:p>
+            <a:pPr defTabSz="685800"/>
+            <a:endParaRPr lang="en-US" sz="1600">
+              <a:solidFill>
+                <a:prstClr val="black"/>
+              </a:solidFill>
+              <a:latin typeface="Aptos"/>
+            </a:endParaRPr>
+          </a:p>
+        </p:txBody>
+      </p:sp>
+      <p:pic>
+        <p:nvPicPr>
+          <p:cNvPr id="11" name="Image 0" descr="/mnt/data/github_qr.png"/>
+          <p:cNvPicPr>
+            <a:picLocks noChangeAspect="1"/>
+          </p:cNvPicPr>
+          <p:nvPr/>
+        </p:nvPicPr>
+        <p:blipFill>
+          <a:blip r:embed="rId3"/>
+          <a:stretch>
+            <a:fillRect/>
+          </a:stretch>
+        </p:blipFill>
+        <p:spPr>
+          <a:xfrm>
+            <a:off x="4766310" y="1748790"/>
+            <a:ext cx="1028700" cy="1028700"/>
+          </a:xfrm>
+          <a:prstGeom prst="rect">
+            <a:avLst/>
+          </a:prstGeom>
+        </p:spPr>
+      </p:pic>
+      <p:sp>
+        <p:nvSpPr>
+          <p:cNvPr id="12" name="Text 9"/>
+          <p:cNvSpPr/>
+          <p:nvPr/>
+        </p:nvSpPr>
+        <p:spPr>
+          <a:xfrm>
+            <a:off x="4745736" y="2894076"/>
+            <a:ext cx="1062990" cy="123444"/>
+          </a:xfrm>
+          <a:prstGeom prst="rect">
+            <a:avLst/>
+          </a:prstGeom>
+          <a:noFill/>
+          <a:ln/>
+        </p:spPr>
+        <p:txBody>
+          <a:bodyPr wrap="square" lIns="0" tIns="0" rIns="0" bIns="0" rtlCol="0" anchor="ctr"/>
+          <a:lstStyle/>
+          <a:p>
+            <a:pPr algn="ctr" defTabSz="685800"/>
+            <a:r>
+              <a:rPr lang="en-US" sz="900" b="1" dirty="0">
+                <a:solidFill>
+                  <a:srgbClr val="F8FAFC"/>
+                </a:solidFill>
+                <a:latin typeface="Aptos"/>
+              </a:rPr>
+              <a:t>GitHub repo</a:t>
+            </a:r>
+            <a:endParaRPr lang="en-US" sz="900" dirty="0">
+              <a:solidFill>
+                <a:prstClr val="black"/>
+              </a:solidFill>
+              <a:latin typeface="Aptos"/>
+            </a:endParaRPr>
+          </a:p>
+        </p:txBody>
+      </p:sp>
+      <p:sp>
+        <p:nvSpPr>
+          <p:cNvPr id="13" name="Shape 10"/>
+          <p:cNvSpPr/>
+          <p:nvPr/>
+        </p:nvSpPr>
+        <p:spPr>
+          <a:xfrm>
+            <a:off x="6412230" y="1508760"/>
+            <a:ext cx="1508760" cy="1748790"/>
+          </a:xfrm>
+          <a:prstGeom prst="roundRect">
+            <a:avLst>
+              <a:gd name="adj" fmla="val 3636"/>
+            </a:avLst>
+          </a:prstGeom>
+          <a:solidFill>
+            <a:srgbClr val="0D1421"/>
+          </a:solidFill>
+          <a:ln w="12700">
+            <a:solidFill>
+              <a:srgbClr val="26364F"/>
+            </a:solidFill>
+            <a:prstDash val="solid"/>
+          </a:ln>
+        </p:spPr>
+        <p:txBody>
+          <a:bodyPr/>
+          <a:lstStyle/>
+          <a:p>
+            <a:pPr defTabSz="685800"/>
+            <a:endParaRPr lang="en-US" sz="1600">
+              <a:solidFill>
+                <a:prstClr val="black"/>
+              </a:solidFill>
+              <a:latin typeface="Aptos"/>
+            </a:endParaRPr>
+          </a:p>
+        </p:txBody>
+      </p:sp>
+      <p:pic>
+        <p:nvPicPr>
+          <p:cNvPr id="14" name="Image 1" descr="/mnt/data/linkedin_qr.png"/>
+          <p:cNvPicPr>
+            <a:picLocks noChangeAspect="1"/>
+          </p:cNvPicPr>
+          <p:nvPr/>
+        </p:nvPicPr>
+        <p:blipFill>
+          <a:blip r:embed="rId4"/>
+          <a:stretch>
+            <a:fillRect/>
+          </a:stretch>
+        </p:blipFill>
+        <p:spPr>
+          <a:xfrm>
+            <a:off x="6652260" y="1748790"/>
+            <a:ext cx="1028700" cy="1028700"/>
+          </a:xfrm>
+          <a:prstGeom prst="rect">
+            <a:avLst/>
+          </a:prstGeom>
+        </p:spPr>
+      </p:pic>
+      <p:sp>
+        <p:nvSpPr>
+          <p:cNvPr id="15" name="Text 11"/>
+          <p:cNvSpPr/>
+          <p:nvPr/>
+        </p:nvSpPr>
+        <p:spPr>
+          <a:xfrm>
+            <a:off x="6652260" y="2894076"/>
+            <a:ext cx="1028700" cy="123444"/>
+          </a:xfrm>
+          <a:prstGeom prst="rect">
+            <a:avLst/>
+          </a:prstGeom>
+          <a:noFill/>
+          <a:ln/>
+        </p:spPr>
+        <p:txBody>
+          <a:bodyPr wrap="square" lIns="0" tIns="0" rIns="0" bIns="0" rtlCol="0" anchor="ctr"/>
+          <a:lstStyle/>
+          <a:p>
+            <a:pPr algn="ctr" defTabSz="685800"/>
+            <a:r>
+              <a:rPr lang="en-US" sz="900" b="1" dirty="0">
+                <a:solidFill>
+                  <a:srgbClr val="F8FAFC"/>
+                </a:solidFill>
+                <a:latin typeface="Aptos"/>
+              </a:rPr>
+              <a:t>LinkedIn</a:t>
+            </a:r>
+            <a:endParaRPr lang="en-US" sz="900" dirty="0">
+              <a:solidFill>
+                <a:prstClr val="black"/>
+              </a:solidFill>
+              <a:latin typeface="Aptos"/>
+            </a:endParaRPr>
+          </a:p>
+        </p:txBody>
+      </p:sp>
+      <p:sp>
+        <p:nvSpPr>
+          <p:cNvPr id="16" name="Shape 12"/>
+          <p:cNvSpPr/>
+          <p:nvPr/>
+        </p:nvSpPr>
+        <p:spPr>
+          <a:xfrm>
+            <a:off x="3655314" y="3819906"/>
+            <a:ext cx="1845129" cy="595342"/>
+          </a:xfrm>
+          <a:prstGeom prst="roundRect">
+            <a:avLst>
+              <a:gd name="adj" fmla="val 25000"/>
+            </a:avLst>
+          </a:prstGeom>
+          <a:solidFill>
+            <a:srgbClr val="0B1220"/>
+          </a:solidFill>
+          <a:ln w="12700">
+            <a:solidFill>
+              <a:srgbClr val="22D3EE">
+                <a:alpha val="90000"/>
+              </a:srgbClr>
+            </a:solidFill>
+            <a:prstDash val="solid"/>
+          </a:ln>
+        </p:spPr>
+        <p:txBody>
+          <a:bodyPr/>
+          <a:lstStyle/>
+          <a:p>
+            <a:pPr defTabSz="685800"/>
+            <a:endParaRPr lang="en-US" sz="1600">
+              <a:solidFill>
+                <a:prstClr val="black"/>
+              </a:solidFill>
+              <a:latin typeface="Aptos"/>
+            </a:endParaRPr>
+          </a:p>
+        </p:txBody>
+      </p:sp>
+      <p:sp>
+        <p:nvSpPr>
+          <p:cNvPr id="17" name="Text 13"/>
+          <p:cNvSpPr/>
+          <p:nvPr/>
+        </p:nvSpPr>
+        <p:spPr>
+          <a:xfrm>
+            <a:off x="3847337" y="3960494"/>
+            <a:ext cx="1447201" cy="250317"/>
+          </a:xfrm>
+          <a:prstGeom prst="rect">
+            <a:avLst/>
+          </a:prstGeom>
+          <a:noFill/>
+          <a:ln/>
+        </p:spPr>
+        <p:txBody>
+          <a:bodyPr wrap="square" lIns="0" tIns="0" rIns="0" bIns="0" rtlCol="0" anchor="ctr"/>
+          <a:lstStyle/>
+          <a:p>
+            <a:pPr algn="ctr" defTabSz="685800"/>
+            <a:r>
+              <a:rPr lang="en-US" sz="1600" b="1" dirty="0">
+                <a:solidFill>
+                  <a:srgbClr val="22D3EE"/>
+                </a:solidFill>
+                <a:latin typeface="Aptos"/>
+              </a:rPr>
+              <a:t>Any questions?</a:t>
+            </a:r>
+            <a:endParaRPr lang="en-US" sz="1600" dirty="0">
+              <a:solidFill>
+                <a:prstClr val="black"/>
+              </a:solidFill>
+              <a:latin typeface="Aptos"/>
+            </a:endParaRPr>
+          </a:p>
+        </p:txBody>
+      </p:sp>
+      <p:sp>
+        <p:nvSpPr>
+          <p:cNvPr id="22" name="Text 0">
+            <a:extLst>
+              <a:ext uri="{FF2B5EF4-FFF2-40B4-BE49-F238E27FC236}">
+                <a16:creationId xmlns:a16="http://schemas.microsoft.com/office/drawing/2014/main" id="{502DA90C-83AD-C169-61EB-5297BFAB999A}"/>
+              </a:ext>
+            </a:extLst>
+          </p:cNvPr>
+          <p:cNvSpPr/>
+          <p:nvPr/>
+        </p:nvSpPr>
+        <p:spPr>
+          <a:xfrm>
+            <a:off x="365760" y="4814316"/>
+            <a:ext cx="5943600" cy="256032"/>
+          </a:xfrm>
+          <a:prstGeom prst="rect">
+            <a:avLst/>
+          </a:prstGeom>
+          <a:noFill/>
+          <a:ln/>
+        </p:spPr>
+        <p:txBody>
+          <a:bodyPr wrap="square" lIns="0" tIns="0" rIns="0" bIns="0" rtlCol="0" anchor="ctr"/>
+          <a:lstStyle/>
+          <a:p>
+            <a:pPr marL="0" indent="0">
+              <a:buNone/>
+            </a:pPr>
+            <a:r>
+              <a:rPr lang="en-US" sz="900" dirty="0">
+                <a:solidFill>
+                  <a:srgbClr val="5B6B8C"/>
+                </a:solidFill>
+                <a:latin typeface="Calibri" pitchFamily="34" charset="0"/>
+                <a:ea typeface="Calibri" pitchFamily="34" charset="-122"/>
+                <a:cs typeface="Calibri" pitchFamily="34" charset="-120"/>
+              </a:rPr>
+              <a:t>PITER AI  ·  AI-Augmented Software Engineering — mid-course project</a:t>
+            </a:r>
+            <a:endParaRPr lang="en-US" sz="900" dirty="0"/>
+          </a:p>
+        </p:txBody>
+      </p:sp>
+      <p:sp>
+        <p:nvSpPr>
+          <p:cNvPr id="24" name="Text 1">
+            <a:extLst>
+              <a:ext uri="{FF2B5EF4-FFF2-40B4-BE49-F238E27FC236}">
+                <a16:creationId xmlns:a16="http://schemas.microsoft.com/office/drawing/2014/main" id="{0F8025E8-9ED0-BD29-317A-66DF9434E1C8}"/>
+              </a:ext>
+            </a:extLst>
+          </p:cNvPr>
+          <p:cNvSpPr/>
+          <p:nvPr/>
+        </p:nvSpPr>
+        <p:spPr>
+          <a:xfrm>
+            <a:off x="6400800" y="4814316"/>
+            <a:ext cx="2377440" cy="256032"/>
+          </a:xfrm>
+          <a:prstGeom prst="rect">
+            <a:avLst/>
+          </a:prstGeom>
+          <a:noFill/>
+          <a:ln/>
+        </p:spPr>
+        <p:txBody>
+          <a:bodyPr wrap="square" lIns="0" tIns="0" rIns="0" bIns="0" rtlCol="0" anchor="ctr"/>
+          <a:lstStyle/>
+          <a:p>
+            <a:pPr marL="0" indent="0" algn="r">
+              <a:buNone/>
+            </a:pPr>
+            <a:r>
+              <a:rPr lang="en-US" sz="900" dirty="0">
+                <a:solidFill>
+                  <a:srgbClr val="5B6B8C"/>
+                </a:solidFill>
+                <a:latin typeface="Calibri" pitchFamily="34" charset="0"/>
+                <a:ea typeface="Calibri" pitchFamily="34" charset="-122"/>
+                <a:cs typeface="Calibri" pitchFamily="34" charset="-120"/>
+              </a:rPr>
+              <a:t> Thank you ·   7 / 7</a:t>
+            </a:r>
+            <a:endParaRPr lang="en-US" sz="900" dirty="0"/>
           </a:p>
         </p:txBody>
       </p:sp>
@@ -9758,6 +10976,301 @@
 </file>
 
 <file path=ppt/theme/theme2.xml><?xml version="1.0" encoding="utf-8"?>
+<a:theme xmlns:a="http://schemas.openxmlformats.org/drawingml/2006/main" name="1_Office Theme">
+  <a:themeElements>
+    <a:clrScheme name="Office">
+      <a:dk1>
+        <a:sysClr val="windowText" lastClr="000000"/>
+      </a:dk1>
+      <a:lt1>
+        <a:sysClr val="window" lastClr="FFFFFF"/>
+      </a:lt1>
+      <a:dk2>
+        <a:srgbClr val="44546A"/>
+      </a:dk2>
+      <a:lt2>
+        <a:srgbClr val="E7E6E6"/>
+      </a:lt2>
+      <a:accent1>
+        <a:srgbClr val="4472C4"/>
+      </a:accent1>
+      <a:accent2>
+        <a:srgbClr val="ED7D31"/>
+      </a:accent2>
+      <a:accent3>
+        <a:srgbClr val="A5A5A5"/>
+      </a:accent3>
+      <a:accent4>
+        <a:srgbClr val="FFC000"/>
+      </a:accent4>
+      <a:accent5>
+        <a:srgbClr val="5B9BD5"/>
+      </a:accent5>
+      <a:accent6>
+        <a:srgbClr val="70AD47"/>
+      </a:accent6>
+      <a:hlink>
+        <a:srgbClr val="0563C1"/>
+      </a:hlink>
+      <a:folHlink>
+        <a:srgbClr val="954F72"/>
+      </a:folHlink>
+    </a:clrScheme>
+    <a:fontScheme name="Office">
+      <a:majorFont>
+        <a:latin typeface="Aptos Display"/>
+        <a:ea typeface=""/>
+        <a:cs typeface=""/>
+        <a:font script="Jpan" typeface="游ゴシック Light"/>
+        <a:font script="Hang" typeface="맑은 고딕"/>
+        <a:font script="Hans" typeface="等线 Light"/>
+        <a:font script="Hant" typeface="新細明體"/>
+        <a:font script="Arab" typeface="Times New Roman"/>
+        <a:font script="Hebr" typeface="Times New Roman"/>
+        <a:font script="Thai" typeface="Angsana New"/>
+        <a:font script="Ethi" typeface="Nyala"/>
+        <a:font script="Beng" typeface="Vrinda"/>
+        <a:font script="Gujr" typeface="Shruti"/>
+        <a:font script="Khmr" typeface="MoolBoran"/>
+        <a:font script="Knda" typeface="Tunga"/>
+        <a:font script="Guru" typeface="Raavi"/>
+        <a:font script="Cans" typeface="Euphemia"/>
+        <a:font script="Cher" typeface="Plantagenet Cherokee"/>
+        <a:font script="Yiii" typeface="Microsoft Yi Baiti"/>
+        <a:font script="Tibt" typeface="Microsoft Himalaya"/>
+        <a:font script="Thaa" typeface="MV Boli"/>
+        <a:font script="Deva" typeface="Mangal"/>
+        <a:font script="Telu" typeface="Gautami"/>
+        <a:font script="Taml" typeface="Latha"/>
+        <a:font script="Syrc" typeface="Estrangelo Edessa"/>
+        <a:font script="Orya" typeface="Kalinga"/>
+        <a:font script="Mlym" typeface="Kartika"/>
+        <a:font script="Laoo" typeface="DokChampa"/>
+        <a:font script="Sinh" typeface="Iskoola Pota"/>
+        <a:font script="Mong" typeface="Mongolian Baiti"/>
+        <a:font script="Viet" typeface="Times New Roman"/>
+        <a:font script="Uigh" typeface="Microsoft Uighur"/>
+        <a:font script="Geor" typeface="Sylfaen"/>
+        <a:font script="Armn" typeface="Arial"/>
+        <a:font script="Bugi" typeface="Leelawadee UI"/>
+        <a:font script="Bopo" typeface="Microsoft JhengHei"/>
+        <a:font script="Java" typeface="Javanese Text"/>
+        <a:font script="Lisu" typeface="Segoe UI"/>
+        <a:font script="Mymr" typeface="Myanmar Text"/>
+        <a:font script="Nkoo" typeface="Ebrima"/>
+        <a:font script="Olck" typeface="Nirmala UI"/>
+        <a:font script="Osma" typeface="Ebrima"/>
+        <a:font script="Phag" typeface="Phagspa"/>
+        <a:font script="Syrn" typeface="Estrangelo Edessa"/>
+        <a:font script="Syrj" typeface="Estrangelo Edessa"/>
+        <a:font script="Syre" typeface="Estrangelo Edessa"/>
+        <a:font script="Sora" typeface="Nirmala UI"/>
+        <a:font script="Tale" typeface="Microsoft Tai Le"/>
+        <a:font script="Talu" typeface="Microsoft New Tai Lue"/>
+        <a:font script="Tfng" typeface="Ebrima"/>
+      </a:majorFont>
+      <a:minorFont>
+        <a:latin typeface="Aptos"/>
+        <a:ea typeface=""/>
+        <a:cs typeface=""/>
+        <a:font script="Jpan" typeface="游ゴシック"/>
+        <a:font script="Hang" typeface="맑은 고딕"/>
+        <a:font script="Hans" typeface="等线"/>
+        <a:font script="Hant" typeface="新細明體"/>
+        <a:font script="Arab" typeface="Arial"/>
+        <a:font script="Hebr" typeface="Arial"/>
+        <a:font script="Thai" typeface="Cordia New"/>
+        <a:font script="Ethi" typeface="Nyala"/>
+        <a:font script="Beng" typeface="Vrinda"/>
+        <a:font script="Gujr" typeface="Shruti"/>
+        <a:font script="Khmr" typeface="DaunPenh"/>
+        <a:font script="Knda" typeface="Tunga"/>
+        <a:font script="Guru" typeface="Raavi"/>
+        <a:font script="Cans" typeface="Euphemia"/>
+        <a:font script="Cher" typeface="Plantagenet Cherokee"/>
+        <a:font script="Yiii" typeface="Microsoft Yi Baiti"/>
+        <a:font script="Tibt" typeface="Microsoft Himalaya"/>
+        <a:font script="Thaa" typeface="MV Boli"/>
+        <a:font script="Deva" typeface="Mangal"/>
+        <a:font script="Telu" typeface="Gautami"/>
+        <a:font script="Taml" typeface="Latha"/>
+        <a:font script="Syrc" typeface="Estrangelo Edessa"/>
+        <a:font script="Orya" typeface="Kalinga"/>
+        <a:font script="Mlym" typeface="Kartika"/>
+        <a:font script="Laoo" typeface="DokChampa"/>
+        <a:font script="Sinh" typeface="Iskoola Pota"/>
+        <a:font script="Mong" typeface="Mongolian Baiti"/>
+        <a:font script="Viet" typeface="Arial"/>
+        <a:font script="Uigh" typeface="Microsoft Uighur"/>
+        <a:font script="Geor" typeface="Sylfaen"/>
+        <a:font script="Armn" typeface="Arial"/>
+        <a:font script="Bugi" typeface="Leelawadee UI"/>
+        <a:font script="Bopo" typeface="Microsoft JhengHei"/>
+        <a:font script="Java" typeface="Javanese Text"/>
+        <a:font script="Lisu" typeface="Segoe UI"/>
+        <a:font script="Mymr" typeface="Myanmar Text"/>
+        <a:font script="Nkoo" typeface="Ebrima"/>
+        <a:font script="Olck" typeface="Nirmala UI"/>
+        <a:font script="Osma" typeface="Ebrima"/>
+        <a:font script="Phag" typeface="Phagspa"/>
+        <a:font script="Syrn" typeface="Estrangelo Edessa"/>
+        <a:font script="Syrj" typeface="Estrangelo Edessa"/>
+        <a:font script="Syre" typeface="Estrangelo Edessa"/>
+        <a:font script="Sora" typeface="Nirmala UI"/>
+        <a:font script="Tale" typeface="Microsoft Tai Le"/>
+        <a:font script="Talu" typeface="Microsoft New Tai Lue"/>
+        <a:font script="Tfng" typeface="Ebrima"/>
+      </a:minorFont>
+    </a:fontScheme>
+    <a:fmtScheme name="Office">
+      <a:fillStyleLst>
+        <a:solidFill>
+          <a:schemeClr val="phClr"/>
+        </a:solidFill>
+        <a:gradFill rotWithShape="1">
+          <a:gsLst>
+            <a:gs pos="0">
+              <a:schemeClr val="phClr">
+                <a:lumMod val="110000"/>
+                <a:satMod val="105000"/>
+                <a:tint val="67000"/>
+              </a:schemeClr>
+            </a:gs>
+            <a:gs pos="50000">
+              <a:schemeClr val="phClr">
+                <a:lumMod val="105000"/>
+                <a:satMod val="103000"/>
+                <a:tint val="73000"/>
+              </a:schemeClr>
+            </a:gs>
+            <a:gs pos="100000">
+              <a:schemeClr val="phClr">
+                <a:lumMod val="105000"/>
+                <a:satMod val="109000"/>
+                <a:tint val="81000"/>
+              </a:schemeClr>
+            </a:gs>
+          </a:gsLst>
+          <a:lin ang="5400000" scaled="0"/>
+        </a:gradFill>
+        <a:gradFill rotWithShape="1">
+          <a:gsLst>
+            <a:gs pos="0">
+              <a:schemeClr val="phClr">
+                <a:satMod val="103000"/>
+                <a:lumMod val="102000"/>
+                <a:tint val="94000"/>
+              </a:schemeClr>
+            </a:gs>
+            <a:gs pos="50000">
+              <a:schemeClr val="phClr">
+                <a:satMod val="110000"/>
+                <a:lumMod val="100000"/>
+                <a:shade val="100000"/>
+              </a:schemeClr>
+            </a:gs>
+            <a:gs pos="100000">
+              <a:schemeClr val="phClr">
+                <a:lumMod val="99000"/>
+                <a:satMod val="120000"/>
+                <a:shade val="78000"/>
+              </a:schemeClr>
+            </a:gs>
+          </a:gsLst>
+          <a:lin ang="5400000" scaled="0"/>
+        </a:gradFill>
+      </a:fillStyleLst>
+      <a:lnStyleLst>
+        <a:ln w="6350" cap="flat" cmpd="sng" algn="ctr">
+          <a:solidFill>
+            <a:schemeClr val="phClr"/>
+          </a:solidFill>
+          <a:prstDash val="solid"/>
+          <a:miter lim="800000"/>
+        </a:ln>
+        <a:ln w="12700" cap="flat" cmpd="sng" algn="ctr">
+          <a:solidFill>
+            <a:schemeClr val="phClr"/>
+          </a:solidFill>
+          <a:prstDash val="solid"/>
+          <a:miter lim="800000"/>
+        </a:ln>
+        <a:ln w="19050" cap="flat" cmpd="sng" algn="ctr">
+          <a:solidFill>
+            <a:schemeClr val="phClr"/>
+          </a:solidFill>
+          <a:prstDash val="solid"/>
+          <a:miter lim="800000"/>
+        </a:ln>
+      </a:lnStyleLst>
+      <a:effectStyleLst>
+        <a:effectStyle>
+          <a:effectLst/>
+        </a:effectStyle>
+        <a:effectStyle>
+          <a:effectLst/>
+        </a:effectStyle>
+        <a:effectStyle>
+          <a:effectLst>
+            <a:outerShdw blurRad="57150" dist="19050" dir="5400000" algn="ctr" rotWithShape="0">
+              <a:srgbClr val="000000">
+                <a:alpha val="63000"/>
+              </a:srgbClr>
+            </a:outerShdw>
+          </a:effectLst>
+        </a:effectStyle>
+      </a:effectStyleLst>
+      <a:bgFillStyleLst>
+        <a:solidFill>
+          <a:schemeClr val="phClr"/>
+        </a:solidFill>
+        <a:solidFill>
+          <a:schemeClr val="phClr">
+            <a:tint val="95000"/>
+            <a:satMod val="170000"/>
+          </a:schemeClr>
+        </a:solidFill>
+        <a:gradFill rotWithShape="1">
+          <a:gsLst>
+            <a:gs pos="0">
+              <a:schemeClr val="phClr">
+                <a:tint val="93000"/>
+                <a:satMod val="150000"/>
+                <a:shade val="98000"/>
+                <a:lumMod val="102000"/>
+              </a:schemeClr>
+            </a:gs>
+            <a:gs pos="50000">
+              <a:schemeClr val="phClr">
+                <a:tint val="98000"/>
+                <a:satMod val="130000"/>
+                <a:shade val="90000"/>
+                <a:lumMod val="103000"/>
+              </a:schemeClr>
+            </a:gs>
+            <a:gs pos="100000">
+              <a:schemeClr val="phClr">
+                <a:shade val="63000"/>
+                <a:satMod val="120000"/>
+              </a:schemeClr>
+            </a:gs>
+          </a:gsLst>
+          <a:lin ang="5400000" scaled="0"/>
+        </a:gradFill>
+      </a:bgFillStyleLst>
+    </a:fmtScheme>
+  </a:themeElements>
+  <a:objectDefaults/>
+  <a:extraClrSchemeLst/>
+  <a:extLst>
+    <a:ext uri="{05A4C25C-085E-4340-85A3-A5531E510DB2}">
+      <thm15:themeFamily xmlns:thm15="http://schemas.microsoft.com/office/thememl/2012/main" name="Office Theme" id="{62F939B6-93AF-4DB8-9C6B-D6C7DFDC589F}" vid="{4A3C46E8-61CC-4603-A589-7422A47A8E4A}"/>
+    </a:ext>
+  </a:extLst>
+</a:theme>
+</file>
+
+<file path=ppt/theme/theme3.xml><?xml version="1.0" encoding="utf-8"?>
 <a:theme xmlns:a="http://schemas.openxmlformats.org/drawingml/2006/main" name="Office Theme">
   <a:themeElements>
     <a:clrScheme name="Office">

</xml_diff>

<commit_message>
Update presentation file with new content and design enhancements for final review
</commit_message>
<xml_diff>
--- a/projects/piter-aiops/presentation/presentation_v1.pptx
+++ b/projects/piter-aiops/presentation/presentation_v1.pptx
@@ -1803,7 +1803,7 @@
                 <a:ea typeface="Calibri" pitchFamily="34" charset="-122"/>
                 <a:cs typeface="Calibri" pitchFamily="34" charset="-120"/>
               </a:rPr>
-              <a:t>Production Operations Analyst — NOC / SRE</a:t>
+              <a:t>Intern AI Engineer @ Amdocs, Specialist Production Operations Analyst NOC / SRE</a:t>
             </a:r>
             <a:endParaRPr lang="en-US" sz="1400" dirty="0"/>
           </a:p>
@@ -1852,7 +1852,7 @@
                 <a:ea typeface="Calibri" pitchFamily="34" charset="-122"/>
                 <a:cs typeface="Calibri" pitchFamily="34" charset="-120"/>
               </a:rPr>
-              <a:t>Software engineer with 2+ years in production operations. </a:t>
+              <a:t>Software engineer with 2+ years experience in production operations. </a:t>
             </a:r>
             <a:r>
               <a:rPr lang="en-US" sz="1300" i="1" dirty="0">
@@ -2014,7 +2014,7 @@
         </p:nvSpPr>
         <p:spPr>
           <a:xfrm>
-            <a:off x="5212080" y="502920"/>
+            <a:off x="5193792" y="502920"/>
             <a:ext cx="3566160" cy="3931920"/>
           </a:xfrm>
           <a:prstGeom prst="roundRect">
@@ -2111,22 +2111,19 @@
         </p:nvSpPr>
         <p:spPr>
           <a:xfrm>
-            <a:off x="5852160" y="978408"/>
-            <a:ext cx="2788920" cy="566928"/>
-          </a:xfrm>
-          <a:prstGeom prst="rect">
-            <a:avLst/>
-          </a:prstGeom>
-          <a:noFill/>
-          <a:ln/>
-        </p:spPr>
-        <p:txBody>
-          <a:bodyPr wrap="square" lIns="0" tIns="0" rIns="0" bIns="0" rtlCol="0" anchor="ctr"/>
-          <a:lstStyle/>
-          <a:p>
-            <a:pPr marL="0" indent="0">
-              <a:buNone/>
-            </a:pPr>
+            <a:off x="5852159" y="978408"/>
+            <a:ext cx="1600201" cy="566928"/>
+          </a:xfrm>
+          <a:prstGeom prst="rect">
+            <a:avLst/>
+          </a:prstGeom>
+          <a:noFill/>
+          <a:ln/>
+        </p:spPr>
+        <p:txBody>
+          <a:bodyPr wrap="square" lIns="0" tIns="0" rIns="0" bIns="0" rtlCol="0" anchor="ctr"/>
+          <a:lstStyle/>
+          <a:p>
             <a:r>
               <a:rPr lang="en-US" sz="1050" dirty="0">
                 <a:solidFill>
@@ -2136,9 +2133,20 @@
                 <a:ea typeface="Calibri" pitchFamily="34" charset="-122"/>
                 <a:cs typeface="Calibri" pitchFamily="34" charset="-120"/>
               </a:rPr>
-              <a:t>The Open University - B.Sc. Computer Science – GPA 91</a:t>
-            </a:r>
-            <a:endParaRPr lang="en-US" sz="1050" dirty="0"/>
+              <a:t>The Open University, B.Sc. Computer Science · </a:t>
+            </a:r>
+            <a:r>
+              <a:rPr lang="en-US" sz="1050" b="1" dirty="0">
+                <a:solidFill>
+                  <a:srgbClr val="9FB0CC"/>
+                </a:solidFill>
+                <a:latin typeface="Calibri" pitchFamily="34" charset="0"/>
+                <a:ea typeface="Calibri" pitchFamily="34" charset="-122"/>
+                <a:cs typeface="Calibri" pitchFamily="34" charset="-120"/>
+              </a:rPr>
+              <a:t>GPA 91</a:t>
+            </a:r>
+            <a:endParaRPr lang="en-US" sz="1050" b="1" dirty="0"/>
           </a:p>
         </p:txBody>
       </p:sp>
@@ -2235,7 +2243,7 @@
                 <a:ea typeface="Calibri" pitchFamily="34" charset="-122"/>
                 <a:cs typeface="Calibri" pitchFamily="34" charset="-120"/>
               </a:rPr>
-              <a:t>2+ years operating production databases and infrastructure across regulated, multi-jurisdiction environments</a:t>
+              <a:t>2+ years of experience supporting production databases and infrastructure in regulated, multi-region environments.</a:t>
             </a:r>
           </a:p>
           <a:p>
@@ -2621,20 +2629,22 @@
           <a:bodyPr wrap="square" lIns="0" tIns="0" rIns="0" bIns="0" rtlCol="0" anchor="ctr"/>
           <a:lstStyle/>
           <a:p>
+            <a:r>
+              <a:rPr lang="en-US" sz="1400" dirty="0">
+                <a:solidFill>
+                  <a:srgbClr val="22D3EE"/>
+                </a:solidFill>
+                <a:latin typeface="Calibri" pitchFamily="34" charset="0"/>
+                <a:ea typeface="Calibri" pitchFamily="34" charset="-122"/>
+                <a:cs typeface="Calibri" pitchFamily="34" charset="-120"/>
+              </a:rPr>
+              <a:t>PITER Ops - Turning production alerts into faster, smarter incident response.</a:t>
+            </a:r>
+          </a:p>
+          <a:p>
             <a:pPr marL="0" indent="0">
               <a:buNone/>
             </a:pPr>
-            <a:r>
-              <a:rPr lang="en-US" sz="1400" dirty="0">
-                <a:solidFill>
-                  <a:srgbClr val="22D3EE"/>
-                </a:solidFill>
-                <a:latin typeface="Calibri" pitchFamily="34" charset="0"/>
-                <a:ea typeface="Calibri" pitchFamily="34" charset="-122"/>
-                <a:cs typeface="Calibri" pitchFamily="34" charset="-120"/>
-              </a:rPr>
-              <a:t>An AI incident-response copilot for production operations teams</a:t>
-            </a:r>
             <a:endParaRPr lang="en-US" sz="1400" dirty="0"/>
           </a:p>
         </p:txBody>
@@ -9409,7 +9419,7 @@
                 <a:ea typeface="Calibri" pitchFamily="34" charset="-122"/>
                 <a:cs typeface="Calibri" pitchFamily="34" charset="-120"/>
               </a:rPr>
-              <a:t> Demo correlation: deploy → replication lag → similar past incident Safe</a:t>
+              <a:t> Demo correlation: deploy → replication lag → similar past incident </a:t>
             </a:r>
           </a:p>
           <a:p>

</xml_diff>